<commit_message>
Refresh two-theme LLM hint comparison decks
</commit_message>
<xml_diff>
--- a/artifacts/llm-before-after/llm-hint-after-editorial.pptx
+++ b/artifacts/llm-before-after/llm-hint-after-editorial.pptx
@@ -111,6 +111,361 @@
     </a:lvl9pPr>
   </p:defaultTextStyle>
 </p:presentation>
+</file>
+
+<file path=ppt/charts/chart1.xml><?xml version="1.0" encoding="utf-8"?>
+<c:chartSpace xmlns:c="http://schemas.openxmlformats.org/drawingml/2006/chart" xmlns:a="http://schemas.openxmlformats.org/drawingml/2006/main" xmlns:r="http://schemas.openxmlformats.org/officeDocument/2006/relationships">
+  <c:date1904 val="0"/>
+  <c:roundedCorners val="1"/>
+  <c:chart>
+    <c:autoTitleDeleted val="1"/>
+    <c:plotArea>
+      <c:layout/>
+      <c:barChart>
+        <c:barDir val="col"/>
+        <c:grouping val="clustered"/>
+        <c:varyColors val="0"/>
+        <c:ser>
+          <c:idx val="0"/>
+          <c:order val="0"/>
+          <c:tx>
+            <c:strRef>
+              <c:f>Sheet1!$B$1</c:f>
+              <c:strCache>
+                <c:ptCount val="1"/>
+                <c:pt idx="0">
+                  <c:v>Coverage</c:v>
+                </c:pt>
+              </c:strCache>
+            </c:strRef>
+          </c:tx>
+          <c:spPr>
+            <a:solidFill>
+              <a:srgbClr val="B45309"/>
+            </a:solidFill>
+            <a:effectLst/>
+          </c:spPr>
+          <c:invertIfNegative val="0"/>
+          <c:dLbls>
+            <c:numFmt formatCode="#,##0" sourceLinked="0"/>
+            <c:txPr>
+              <a:bodyPr/>
+              <a:lstStyle/>
+              <a:p>
+                <a:pPr>
+                  <a:defRPr b="0" i="0" strike="noStrike" sz="1200" u="none">
+                    <a:solidFill>
+                      <a:srgbClr val="000000"/>
+                    </a:solidFill>
+                    <a:latin typeface="Arial"/>
+                  </a:defRPr>
+                </a:pPr>
+              </a:p>
+            </c:txPr>
+            <c:showLegendKey val="0"/>
+            <c:showVal val="1"/>
+            <c:showCatName val="0"/>
+            <c:showSerName val="0"/>
+            <c:showPercent val="0"/>
+            <c:showBubbleSize val="0"/>
+            <c:showLeaderLines val="0"/>
+          </c:dLbls>
+          <c:cat>
+            <c:multiLvlStrRef>
+              <c:f>Sheet1!$A$2:$A$5</c:f>
+              <c:multiLvlStrCache>
+                <c:ptCount val="4"/>
+                <c:lvl>
+                  <c:pt idx="0">
+                    <c:v>Elements</c:v>
+                  </c:pt>
+                  <c:pt idx="1">
+                    <c:v>Tables</c:v>
+                  </c:pt>
+                  <c:pt idx="2">
+                    <c:v>Charts</c:v>
+                  </c:pt>
+                  <c:pt idx="3">
+                    <c:v>Theme XML</c:v>
+                  </c:pt>
+                </c:lvl>
+              </c:multiLvlStrCache>
+            </c:multiLvlStrRef>
+          </c:cat>
+          <c:val>
+            <c:numRef>
+              <c:f>Sheet1!$B$2:$B$5</c:f>
+              <c:numCache>
+                <c:formatCode>General</c:formatCode>
+                <c:ptCount val="4"/>
+                <c:pt idx="0">
+                  <c:v>4</c:v>
+                </c:pt>
+                <c:pt idx="1">
+                  <c:v>3</c:v>
+                </c:pt>
+                <c:pt idx="2">
+                  <c:v>4</c:v>
+                </c:pt>
+                <c:pt idx="3">
+                  <c:v>6</c:v>
+                </c:pt>
+              </c:numCache>
+            </c:numRef>
+          </c:val>
+        </c:ser>
+        <c:ser>
+          <c:idx val="1"/>
+          <c:order val="1"/>
+          <c:tx>
+            <c:strRef>
+              <c:f>Sheet1!$C$1</c:f>
+              <c:strCache>
+                <c:ptCount val="1"/>
+                <c:pt idx="0">
+                  <c:v>Validation</c:v>
+                </c:pt>
+              </c:strCache>
+            </c:strRef>
+          </c:tx>
+          <c:spPr>
+            <a:solidFill>
+              <a:srgbClr val="09B453"/>
+            </a:solidFill>
+            <a:effectLst/>
+          </c:spPr>
+          <c:invertIfNegative val="0"/>
+          <c:dLbls>
+            <c:numFmt formatCode="#,##0" sourceLinked="0"/>
+            <c:txPr>
+              <a:bodyPr/>
+              <a:lstStyle/>
+              <a:p>
+                <a:pPr>
+                  <a:defRPr b="0" i="0" strike="noStrike" sz="1200" u="none">
+                    <a:solidFill>
+                      <a:srgbClr val="000000"/>
+                    </a:solidFill>
+                    <a:latin typeface="Arial"/>
+                  </a:defRPr>
+                </a:pPr>
+              </a:p>
+            </c:txPr>
+            <c:showLegendKey val="0"/>
+            <c:showVal val="1"/>
+            <c:showCatName val="0"/>
+            <c:showSerName val="0"/>
+            <c:showPercent val="0"/>
+            <c:showBubbleSize val="0"/>
+            <c:showLeaderLines val="0"/>
+          </c:dLbls>
+          <c:cat>
+            <c:multiLvlStrRef>
+              <c:f>Sheet1!$A$2:$A$5</c:f>
+              <c:multiLvlStrCache>
+                <c:ptCount val="4"/>
+                <c:lvl>
+                  <c:pt idx="0">
+                    <c:v>Elements</c:v>
+                  </c:pt>
+                  <c:pt idx="1">
+                    <c:v>Tables</c:v>
+                  </c:pt>
+                  <c:pt idx="2">
+                    <c:v>Charts</c:v>
+                  </c:pt>
+                  <c:pt idx="3">
+                    <c:v>Theme XML</c:v>
+                  </c:pt>
+                </c:lvl>
+              </c:multiLvlStrCache>
+            </c:multiLvlStrRef>
+          </c:cat>
+          <c:val>
+            <c:numRef>
+              <c:f>Sheet1!$C$2:$C$5</c:f>
+              <c:numCache>
+                <c:formatCode>General</c:formatCode>
+                <c:ptCount val="4"/>
+                <c:pt idx="0">
+                  <c:v>3</c:v>
+                </c:pt>
+                <c:pt idx="1">
+                  <c:v>4</c:v>
+                </c:pt>
+                <c:pt idx="2">
+                  <c:v>3</c:v>
+                </c:pt>
+                <c:pt idx="3">
+                  <c:v>5</c:v>
+                </c:pt>
+              </c:numCache>
+            </c:numRef>
+          </c:val>
+        </c:ser>
+        <c:dLbls>
+          <c:numFmt formatCode="#,##0" sourceLinked="0"/>
+          <c:txPr>
+            <a:bodyPr/>
+            <a:lstStyle/>
+            <a:p>
+              <a:pPr>
+                <a:defRPr b="0" i="0" strike="noStrike" sz="1200" u="none">
+                  <a:solidFill>
+                    <a:srgbClr val="000000"/>
+                  </a:solidFill>
+                  <a:latin typeface="Arial"/>
+                </a:defRPr>
+              </a:pPr>
+            </a:p>
+          </c:txPr>
+          <c:showLegendKey val="0"/>
+          <c:showVal val="1"/>
+          <c:showCatName val="0"/>
+          <c:showSerName val="0"/>
+          <c:showPercent val="0"/>
+          <c:showBubbleSize val="0"/>
+          <c:showLeaderLines val="0"/>
+        </c:dLbls>
+        <c:gapWidth val="150"/>
+        <c:overlap val="0"/>
+        <c:axId val="2094734554"/>
+        <c:axId val="2094734552"/>
+        <c:axId val="2094734556"/>
+      </c:barChart>
+      <c:catAx>
+        <c:axId val="2094734554"/>
+        <c:scaling>
+          <c:orientation val="minMax"/>
+        </c:scaling>
+        <c:delete val="0"/>
+        <c:axPos val="b"/>
+        <c:numFmt formatCode="General" sourceLinked="1"/>
+        <c:majorTickMark val="out"/>
+        <c:minorTickMark val="none"/>
+        <c:tickLblPos val="low"/>
+        <c:spPr>
+          <a:ln w="12700" cap="flat">
+            <a:solidFill>
+              <a:srgbClr val="888888"/>
+            </a:solidFill>
+            <a:prstDash val="solid"/>
+            <a:round/>
+          </a:ln>
+        </c:spPr>
+        <c:txPr>
+          <a:bodyPr/>
+          <a:lstStyle/>
+          <a:p>
+            <a:pPr>
+              <a:defRPr sz="1100" b="0" i="0" u="none" strike="noStrike">
+                <a:solidFill>
+                  <a:srgbClr val="1F2937"/>
+                </a:solidFill>
+                <a:latin typeface="Pretendard"/>
+              </a:defRPr>
+            </a:pPr>
+            <a:endParaRPr lang="en-US"/>
+          </a:p>
+        </c:txPr>
+        <c:crossAx val="2094734552"/>
+        <c:crosses val="autoZero"/>
+        <c:auto val="1"/>
+        <c:lblAlgn val="ctr"/>
+        <c:noMultiLvlLbl val="1"/>
+      </c:catAx>
+      <c:valAx>
+        <c:axId val="2094734552"/>
+        <c:scaling>
+          <c:orientation val="minMax"/>
+        </c:scaling>
+        <c:delete val="0"/>
+        <c:axPos val="l"/>
+        <c:majorGridlines>
+          <c:spPr>
+            <a:ln w="12700" cap="flat">
+              <a:solidFill>
+                <a:srgbClr val="E3CDBA"/>
+              </a:solidFill>
+              <a:prstDash val="solid"/>
+              <a:round/>
+            </a:ln>
+          </c:spPr>
+        </c:majorGridlines>
+        <c:numFmt formatCode="General" sourceLinked="0"/>
+        <c:majorTickMark val="out"/>
+        <c:minorTickMark val="none"/>
+        <c:tickLblPos val="nextTo"/>
+        <c:spPr>
+          <a:ln w="12700" cap="flat">
+            <a:solidFill>
+              <a:srgbClr val="888888"/>
+            </a:solidFill>
+            <a:prstDash val="solid"/>
+            <a:round/>
+          </a:ln>
+        </c:spPr>
+        <c:txPr>
+          <a:bodyPr/>
+          <a:lstStyle/>
+          <a:p>
+            <a:pPr>
+              <a:defRPr sz="1100" b="0" i="0" u="none" strike="noStrike">
+                <a:solidFill>
+                  <a:srgbClr val="57534E"/>
+                </a:solidFill>
+                <a:latin typeface="Pretendard"/>
+              </a:defRPr>
+            </a:pPr>
+            <a:endParaRPr lang="en-US"/>
+          </a:p>
+        </c:txPr>
+        <c:crossAx val="2094734554"/>
+        <c:crosses val="autoZero"/>
+        <c:crossBetween val="between"/>
+      </c:valAx>
+      <c:spPr>
+        <a:noFill/>
+        <a:ln>
+          <a:noFill/>
+        </a:ln>
+        <a:effectLst/>
+      </c:spPr>
+    </c:plotArea>
+    <c:legend>
+      <c:legendPos val="b"/>
+      <c:overlay val="0"/>
+      <c:txPr>
+        <a:bodyPr/>
+        <a:lstStyle/>
+        <a:p>
+          <a:pPr>
+            <a:defRPr sz="1100">
+              <a:solidFill>
+                <a:srgbClr val="57534E"/>
+              </a:solidFill>
+              <a:latin typeface="Pretendard"/>
+              <a:cs typeface="Pretendard"/>
+            </a:defRPr>
+          </a:pPr>
+          <a:endParaRPr lang="en-US"/>
+        </a:p>
+      </c:txPr>
+    </c:legend>
+    <c:plotVisOnly val="1"/>
+    <c:dispBlanksAs val="span"/>
+  </c:chart>
+  <c:spPr>
+    <a:noFill/>
+    <a:ln>
+      <a:noFill/>
+    </a:ln>
+    <a:effectLst/>
+  </c:spPr>
+  <c:externalData r:id="rId1">
+    <c:autoUpdate val="0"/>
+  </c:externalData>
+</c:chartSpace>
 </file>
 
 <file path=ppt/notesMasters/notesMaster1.xml><?xml version="1.0" encoding="utf-8"?>
@@ -2443,19 +2798,21 @@
         </p:nvSpPr>
         <p:spPr>
           <a:xfrm>
-            <a:off x="914400" y="1463040"/>
-            <a:ext cx="10241280" cy="73152"/>
-          </a:xfrm>
-          <a:prstGeom prst="rect">
-            <a:avLst/>
-          </a:prstGeom>
-          <a:solidFill>
-            <a:srgbClr val="B45309"/>
-          </a:solidFill>
-          <a:ln w="12700">
-            <a:solidFill>
-              <a:srgbClr val="B45309">
-                <a:alpha val="0"/>
+            <a:off x="749808" y="1508760"/>
+            <a:ext cx="4617720" cy="3429000"/>
+          </a:xfrm>
+          <a:prstGeom prst="roundRect">
+            <a:avLst>
+              <a:gd name="adj" fmla="val 1600"/>
+            </a:avLst>
+          </a:prstGeom>
+          <a:solidFill>
+            <a:srgbClr val="FBF7F2"/>
+          </a:solidFill>
+          <a:ln w="12700">
+            <a:solidFill>
+              <a:srgbClr val="E3CDBA">
+                <a:alpha val="90000"/>
               </a:srgbClr>
             </a:solidFill>
             <a:prstDash val="solid"/>
@@ -2464,7 +2821,36 @@
       </p:sp>
       <p:sp>
         <p:nvSpPr>
-          <p:cNvPr id="6" name="Text 4"/>
+          <p:cNvPr id="6" name="Shape 4"/>
+          <p:cNvSpPr/>
+          <p:nvPr/>
+        </p:nvSpPr>
+        <p:spPr>
+          <a:xfrm>
+            <a:off x="5577840" y="1572768"/>
+            <a:ext cx="5532120" cy="2999232"/>
+          </a:xfrm>
+          <a:prstGeom prst="roundRect">
+            <a:avLst>
+              <a:gd name="adj" fmla="val 1829"/>
+            </a:avLst>
+          </a:prstGeom>
+          <a:solidFill>
+            <a:srgbClr val="FBF7F2"/>
+          </a:solidFill>
+          <a:ln w="12700">
+            <a:solidFill>
+              <a:srgbClr val="E3CDBA">
+                <a:alpha val="90000"/>
+              </a:srgbClr>
+            </a:solidFill>
+            <a:prstDash val="solid"/>
+          </a:ln>
+        </p:spPr>
+      </p:sp>
+      <p:sp>
+        <p:nvSpPr>
+          <p:cNvPr id="7" name="Text 5"/>
           <p:cNvSpPr txBox="1"/>
           <p:nvPr/>
         </p:nvSpPr>
@@ -2508,6 +2894,22 @@
       </p:sp>
       <p:graphicFrame>
         <p:nvGraphicFramePr>
+          <p:cNvPr id="8" name="Chart 0" descr=""/>
+          <p:cNvGraphicFramePr/>
+          <p:nvPr/>
+        </p:nvGraphicFramePr>
+        <p:xfrm>
+          <a:off x="877824" y="1655064"/>
+          <a:ext cx="4361688" cy="3136392"/>
+        </p:xfrm>
+        <a:graphic xmlns:a="http://schemas.openxmlformats.org/drawingml/2006/main">
+          <a:graphicData uri="http://schemas.openxmlformats.org/drawingml/2006/chart">
+            <c:chart xmlns:c="http://schemas.openxmlformats.org/drawingml/2006/chart" r:id="rId1"/>
+          </a:graphicData>
+        </a:graphic>
+      </p:graphicFrame>
+      <p:graphicFrame>
+        <p:nvGraphicFramePr>
           <p:cNvPr id="5" name="Table 0"/>
           <p:cNvGraphicFramePr>
             <a:graphicFrameLocks noGrp="1"/>
@@ -2521,19 +2923,19 @@
           </p:nvPr>
         </p:nvGraphicFramePr>
         <p:xfrm>
-          <a:off x="914400" y="1463040"/>
-          <a:ext cx="10241280" cy="4480560"/>
+          <a:off x="5577840" y="1572768"/>
+          <a:ext cx="5532120" cy="2999232"/>
         </p:xfrm>
         <a:graphic>
           <a:graphicData uri="http://schemas.openxmlformats.org/drawingml/2006/table">
             <a:tbl>
               <a:tblPr/>
               <a:tblGrid>
-                <a:gridCol w="3413760"/>
-                <a:gridCol w="3413760"/>
-                <a:gridCol w="3413760"/>
+                <a:gridCol w="1844040"/>
+                <a:gridCol w="1844040"/>
+                <a:gridCol w="1844040"/>
               </a:tblGrid>
-              <a:tr h="896112">
+              <a:tr h="599846">
                 <a:tc>
                   <a:txBody>
                     <a:bodyPr/>
@@ -2543,7 +2945,7 @@
                         <a:buNone/>
                       </a:pPr>
                       <a:r>
-                        <a:rPr lang="en-US" sz="2200" b="1" dirty="0">
+                        <a:rPr lang="en-US" sz="1600" b="1" dirty="0">
                           <a:solidFill>
                             <a:srgbClr val="FFFFFF"/>
                           </a:solidFill>
@@ -2553,7 +2955,7 @@
                         </a:rPr>
                         <a:t>Target</a:t>
                       </a:r>
-                      <a:endParaRPr lang="en-US" sz="2200" dirty="0">
+                      <a:endParaRPr lang="en-US" sz="1600" dirty="0">
                         <a:latin typeface="Pretendard" charset="0"/>
                         <a:ea typeface="Pretendard" charset="0"/>
                         <a:cs typeface="Pretendard" charset="0"/>
@@ -2611,7 +3013,7 @@
                         <a:buNone/>
                       </a:pPr>
                       <a:r>
-                        <a:rPr lang="en-US" sz="2200" b="1" dirty="0">
+                        <a:rPr lang="en-US" sz="1600" b="1" dirty="0">
                           <a:solidFill>
                             <a:srgbClr val="FFFFFF"/>
                           </a:solidFill>
@@ -2621,7 +3023,7 @@
                         </a:rPr>
                         <a:t>MDPR-owned behavior</a:t>
                       </a:r>
-                      <a:endParaRPr lang="en-US" sz="2200" dirty="0">
+                      <a:endParaRPr lang="en-US" sz="1600" dirty="0">
                         <a:latin typeface="Pretendard" charset="0"/>
                         <a:ea typeface="Pretendard" charset="0"/>
                         <a:cs typeface="Pretendard" charset="0"/>
@@ -2679,7 +3081,7 @@
                         <a:buNone/>
                       </a:pPr>
                       <a:r>
-                        <a:rPr lang="en-US" sz="2200" b="1" dirty="0">
+                        <a:rPr lang="en-US" sz="1600" b="1" dirty="0">
                           <a:solidFill>
                             <a:srgbClr val="FFFFFF"/>
                           </a:solidFill>
@@ -2689,7 +3091,7 @@
                         </a:rPr>
                         <a:t>Validation signal</a:t>
                       </a:r>
-                      <a:endParaRPr lang="en-US" sz="2200" dirty="0">
+                      <a:endParaRPr lang="en-US" sz="1600" dirty="0">
                         <a:latin typeface="Pretendard" charset="0"/>
                         <a:ea typeface="Pretendard" charset="0"/>
                         <a:cs typeface="Pretendard" charset="0"/>
@@ -2739,7 +3141,7 @@
                   </a:tcPr>
                 </a:tc>
               </a:tr>
-              <a:tr h="896112">
+              <a:tr h="599846">
                 <a:tc>
                   <a:txBody>
                     <a:bodyPr/>
@@ -2749,7 +3151,7 @@
                         <a:buNone/>
                       </a:pPr>
                       <a:r>
-                        <a:rPr lang="en-US" sz="2100" dirty="0">
+                        <a:rPr lang="en-US" sz="1500" dirty="0">
                           <a:solidFill>
                             <a:srgbClr val="1F2937"/>
                           </a:solidFill>
@@ -2759,7 +3161,7 @@
                         </a:rPr>
                         <a:t>Elements</a:t>
                       </a:r>
-                      <a:endParaRPr lang="en-US" sz="2100" dirty="0">
+                      <a:endParaRPr lang="en-US" sz="1500" dirty="0">
                         <a:latin typeface="Pretendard" charset="0"/>
                         <a:ea typeface="Pretendard" charset="0"/>
                         <a:cs typeface="Pretendard" charset="0"/>
@@ -2814,7 +3216,7 @@
                         <a:buNone/>
                       </a:pPr>
                       <a:r>
-                        <a:rPr lang="en-US" sz="2100" dirty="0">
+                        <a:rPr lang="en-US" sz="1500" dirty="0">
                           <a:solidFill>
                             <a:srgbClr val="1F2937"/>
                           </a:solidFill>
@@ -2824,7 +3226,7 @@
                         </a:rPr>
                         <a:t>Apply active design preset and color combination</a:t>
                       </a:r>
-                      <a:endParaRPr lang="en-US" sz="2100" dirty="0">
+                      <a:endParaRPr lang="en-US" sz="1500" dirty="0">
                         <a:latin typeface="Pretendard" charset="0"/>
                         <a:ea typeface="Pretendard" charset="0"/>
                         <a:cs typeface="Pretendard" charset="0"/>
@@ -2879,7 +3281,7 @@
                         <a:buNone/>
                       </a:pPr>
                       <a:r>
-                        <a:rPr lang="en-US" sz="2100" dirty="0">
+                        <a:rPr lang="en-US" sz="1500" dirty="0">
                           <a:solidFill>
                             <a:srgbClr val="1F2937"/>
                           </a:solidFill>
@@ -2889,7 +3291,7 @@
                         </a:rPr>
                         <a:t>Accents stay coherent</a:t>
                       </a:r>
-                      <a:endParaRPr lang="en-US" sz="2100" dirty="0">
+                      <a:endParaRPr lang="en-US" sz="1500" dirty="0">
                         <a:latin typeface="Pretendard" charset="0"/>
                         <a:ea typeface="Pretendard" charset="0"/>
                         <a:cs typeface="Pretendard" charset="0"/>
@@ -2936,7 +3338,7 @@
                   </a:tcPr>
                 </a:tc>
               </a:tr>
-              <a:tr h="896112">
+              <a:tr h="599846">
                 <a:tc>
                   <a:txBody>
                     <a:bodyPr/>
@@ -2946,7 +3348,7 @@
                         <a:buNone/>
                       </a:pPr>
                       <a:r>
-                        <a:rPr lang="en-US" sz="2100" dirty="0">
+                        <a:rPr lang="en-US" sz="1500" dirty="0">
                           <a:solidFill>
                             <a:srgbClr val="1F2937"/>
                           </a:solidFill>
@@ -2956,7 +3358,7 @@
                         </a:rPr>
                         <a:t>Tables</a:t>
                       </a:r>
-                      <a:endParaRPr lang="en-US" sz="2100" dirty="0">
+                      <a:endParaRPr lang="en-US" sz="1500" dirty="0">
                         <a:latin typeface="Pretendard" charset="0"/>
                         <a:ea typeface="Pretendard" charset="0"/>
                         <a:cs typeface="Pretendard" charset="0"/>
@@ -3011,7 +3413,7 @@
                         <a:buNone/>
                       </a:pPr>
                       <a:r>
-                        <a:rPr lang="en-US" sz="2100" dirty="0">
+                        <a:rPr lang="en-US" sz="1500" dirty="0">
                           <a:solidFill>
                             <a:srgbClr val="1F2937"/>
                           </a:solidFill>
@@ -3021,7 +3423,7 @@
                         </a:rPr>
                         <a:t>Use preset header fill, border, and readable minimum font</a:t>
                       </a:r>
-                      <a:endParaRPr lang="en-US" sz="2100" dirty="0">
+                      <a:endParaRPr lang="en-US" sz="1500" dirty="0">
                         <a:latin typeface="Pretendard" charset="0"/>
                         <a:ea typeface="Pretendard" charset="0"/>
                         <a:cs typeface="Pretendard" charset="0"/>
@@ -3076,7 +3478,7 @@
                         <a:buNone/>
                       </a:pPr>
                       <a:r>
-                        <a:rPr lang="en-US" sz="2100" dirty="0">
+                        <a:rPr lang="en-US" sz="1500" dirty="0">
                           <a:solidFill>
                             <a:srgbClr val="1F2937"/>
                           </a:solidFill>
@@ -3086,7 +3488,7 @@
                         </a:rPr>
                         <a:t>Cells remain aligned</a:t>
                       </a:r>
-                      <a:endParaRPr lang="en-US" sz="2100" dirty="0">
+                      <a:endParaRPr lang="en-US" sz="1500" dirty="0">
                         <a:latin typeface="Pretendard" charset="0"/>
                         <a:ea typeface="Pretendard" charset="0"/>
                         <a:cs typeface="Pretendard" charset="0"/>
@@ -3133,7 +3535,7 @@
                   </a:tcPr>
                 </a:tc>
               </a:tr>
-              <a:tr h="896112">
+              <a:tr h="599846">
                 <a:tc>
                   <a:txBody>
                     <a:bodyPr/>
@@ -3143,7 +3545,7 @@
                         <a:buNone/>
                       </a:pPr>
                       <a:r>
-                        <a:rPr lang="en-US" sz="2100" dirty="0">
+                        <a:rPr lang="en-US" sz="1500" dirty="0">
                           <a:solidFill>
                             <a:srgbClr val="1F2937"/>
                           </a:solidFill>
@@ -3153,7 +3555,7 @@
                         </a:rPr>
                         <a:t>Charts</a:t>
                       </a:r>
-                      <a:endParaRPr lang="en-US" sz="2100" dirty="0">
+                      <a:endParaRPr lang="en-US" sz="1500" dirty="0">
                         <a:latin typeface="Pretendard" charset="0"/>
                         <a:ea typeface="Pretendard" charset="0"/>
                         <a:cs typeface="Pretendard" charset="0"/>
@@ -3208,7 +3610,7 @@
                         <a:buNone/>
                       </a:pPr>
                       <a:r>
-                        <a:rPr lang="en-US" sz="2100" dirty="0">
+                        <a:rPr lang="en-US" sz="1500" dirty="0">
                           <a:solidFill>
                             <a:srgbClr val="1F2937"/>
                           </a:solidFill>
@@ -3216,9 +3618,9 @@
                           <a:ea typeface="Pretendard" pitchFamily="34" charset="-122"/>
                           <a:cs typeface="Pretendard" pitchFamily="34" charset="-120"/>
                         </a:rPr>
-                        <a:t>Expose chart color tokens from the same palette</a:t>
+                        <a:t>Render native PowerPoint charts from theme chart tokens</a:t>
                       </a:r>
-                      <a:endParaRPr lang="en-US" sz="2100" dirty="0">
+                      <a:endParaRPr lang="en-US" sz="1500" dirty="0">
                         <a:latin typeface="Pretendard" charset="0"/>
                         <a:ea typeface="Pretendard" charset="0"/>
                         <a:cs typeface="Pretendard" charset="0"/>
@@ -3273,7 +3675,7 @@
                         <a:buNone/>
                       </a:pPr>
                       <a:r>
-                        <a:rPr lang="en-US" sz="2100" dirty="0">
+                        <a:rPr lang="en-US" sz="1500" dirty="0">
                           <a:solidFill>
                             <a:srgbClr val="1F2937"/>
                           </a:solidFill>
@@ -3281,9 +3683,9 @@
                           <a:ea typeface="Pretendard" pitchFamily="34" charset="-122"/>
                           <a:cs typeface="Pretendard" pitchFamily="34" charset="-120"/>
                         </a:rPr>
-                        <a:t>Future chart renderer inherits theme</a:t>
+                        <a:t>Chart series inherit the active harmony</a:t>
                       </a:r>
-                      <a:endParaRPr lang="en-US" sz="2100" dirty="0">
+                      <a:endParaRPr lang="en-US" sz="1500" dirty="0">
                         <a:latin typeface="Pretendard" charset="0"/>
                         <a:ea typeface="Pretendard" charset="0"/>
                         <a:cs typeface="Pretendard" charset="0"/>
@@ -3330,7 +3732,7 @@
                   </a:tcPr>
                 </a:tc>
               </a:tr>
-              <a:tr h="896112">
+              <a:tr h="599846">
                 <a:tc>
                   <a:txBody>
                     <a:bodyPr/>
@@ -3340,7 +3742,7 @@
                         <a:buNone/>
                       </a:pPr>
                       <a:r>
-                        <a:rPr lang="en-US" sz="2100" dirty="0">
+                        <a:rPr lang="en-US" sz="1500" dirty="0">
                           <a:solidFill>
                             <a:srgbClr val="1F2937"/>
                           </a:solidFill>
@@ -3350,7 +3752,7 @@
                         </a:rPr>
                         <a:t>PowerPoint</a:t>
                       </a:r>
-                      <a:endParaRPr lang="en-US" sz="2100" dirty="0">
+                      <a:endParaRPr lang="en-US" sz="1500" dirty="0">
                         <a:latin typeface="Pretendard" charset="0"/>
                         <a:ea typeface="Pretendard" charset="0"/>
                         <a:cs typeface="Pretendard" charset="0"/>
@@ -3405,7 +3807,7 @@
                         <a:buNone/>
                       </a:pPr>
                       <a:r>
-                        <a:rPr lang="en-US" sz="2100" dirty="0">
+                        <a:rPr lang="en-US" sz="1500" dirty="0">
                           <a:solidFill>
                             <a:srgbClr val="1F2937"/>
                           </a:solidFill>
@@ -3415,7 +3817,7 @@
                         </a:rPr>
                         <a:t>Write `accent1` through `accent6` into document theme XML</a:t>
                       </a:r>
-                      <a:endParaRPr lang="en-US" sz="2100" dirty="0">
+                      <a:endParaRPr lang="en-US" sz="1500" dirty="0">
                         <a:latin typeface="Pretendard" charset="0"/>
                         <a:ea typeface="Pretendard" charset="0"/>
                         <a:cs typeface="Pretendard" charset="0"/>
@@ -3470,7 +3872,7 @@
                         <a:buNone/>
                       </a:pPr>
                       <a:r>
-                        <a:rPr lang="en-US" sz="2100" dirty="0">
+                        <a:rPr lang="en-US" sz="1500" dirty="0">
                           <a:solidFill>
                             <a:srgbClr val="1F2937"/>
                           </a:solidFill>
@@ -3480,7 +3882,7 @@
                         </a:rPr>
                         <a:t>User edits keep palette</a:t>
                       </a:r>
-                      <a:endParaRPr lang="en-US" sz="2100" dirty="0">
+                      <a:endParaRPr lang="en-US" sz="1500" dirty="0">
                         <a:latin typeface="Pretendard" charset="0"/>
                         <a:ea typeface="Pretendard" charset="0"/>
                         <a:cs typeface="Pretendard" charset="0"/>
@@ -3652,8 +4054,8 @@
         </p:nvSpPr>
         <p:spPr>
           <a:xfrm>
-            <a:off x="914400" y="1463040"/>
-            <a:ext cx="10241280" cy="73152"/>
+            <a:off x="822960" y="1572768"/>
+            <a:ext cx="6629400" cy="73152"/>
           </a:xfrm>
           <a:prstGeom prst="rect">
             <a:avLst/>
@@ -3673,7 +4075,180 @@
       </p:sp>
       <p:sp>
         <p:nvSpPr>
-          <p:cNvPr id="6" name="Text 4"/>
+          <p:cNvPr id="6" name="Shape 4"/>
+          <p:cNvSpPr/>
+          <p:nvPr/>
+        </p:nvSpPr>
+        <p:spPr>
+          <a:xfrm>
+            <a:off x="7955280" y="1993392"/>
+            <a:ext cx="2139696" cy="2139696"/>
+          </a:xfrm>
+          <a:prstGeom prst="roundRect">
+            <a:avLst>
+              <a:gd name="adj" fmla="val 3419"/>
+            </a:avLst>
+          </a:prstGeom>
+          <a:solidFill>
+            <a:srgbClr val="FBF7F2"/>
+          </a:solidFill>
+          <a:ln w="12700">
+            <a:solidFill>
+              <a:srgbClr val="E3CDBA"/>
+            </a:solidFill>
+            <a:prstDash val="solid"/>
+          </a:ln>
+          <a:effectLst>
+            <a:outerShdw sx="100000" sy="100000" kx="0" ky="0" algn="bl" rotWithShape="0" blurRad="12700" dist="50800" dir="2700000">
+              <a:srgbClr val="000000">
+                <a:alpha val="8000"/>
+              </a:srgbClr>
+            </a:outerShdw>
+          </a:effectLst>
+        </p:spPr>
+      </p:sp>
+      <p:sp>
+        <p:nvSpPr>
+          <p:cNvPr id="7" name="Shape 5"/>
+          <p:cNvSpPr/>
+          <p:nvPr/>
+        </p:nvSpPr>
+        <p:spPr>
+          <a:xfrm>
+            <a:off x="8511601" y="2464125"/>
+            <a:ext cx="575150" cy="742902"/>
+          </a:xfrm>
+          <a:prstGeom prst="roundRect">
+            <a:avLst>
+              <a:gd name="adj" fmla="val 6359"/>
+            </a:avLst>
+          </a:prstGeom>
+          <a:solidFill>
+            <a:srgbClr val="1F2937"/>
+          </a:solidFill>
+          <a:ln w="12700">
+            <a:solidFill>
+              <a:srgbClr val="1F2937">
+                <a:alpha val="0"/>
+              </a:srgbClr>
+            </a:solidFill>
+            <a:prstDash val="solid"/>
+          </a:ln>
+        </p:spPr>
+      </p:sp>
+      <p:sp>
+        <p:nvSpPr>
+          <p:cNvPr id="8" name="Shape 6"/>
+          <p:cNvSpPr/>
+          <p:nvPr/>
+        </p:nvSpPr>
+        <p:spPr>
+          <a:xfrm>
+            <a:off x="8655389" y="2655842"/>
+            <a:ext cx="299557" cy="41938"/>
+          </a:xfrm>
+          <a:prstGeom prst="rect">
+            <a:avLst/>
+          </a:prstGeom>
+          <a:solidFill>
+            <a:srgbClr val="FBF7F2"/>
+          </a:solidFill>
+          <a:ln w="12700">
+            <a:solidFill>
+              <a:srgbClr val="FBF7F2">
+                <a:alpha val="0"/>
+              </a:srgbClr>
+            </a:solidFill>
+            <a:prstDash val="solid"/>
+          </a:ln>
+        </p:spPr>
+      </p:sp>
+      <p:sp>
+        <p:nvSpPr>
+          <p:cNvPr id="9" name="Shape 7"/>
+          <p:cNvSpPr/>
+          <p:nvPr/>
+        </p:nvSpPr>
+        <p:spPr>
+          <a:xfrm>
+            <a:off x="8655389" y="2811612"/>
+            <a:ext cx="299557" cy="41938"/>
+          </a:xfrm>
+          <a:prstGeom prst="rect">
+            <a:avLst/>
+          </a:prstGeom>
+          <a:solidFill>
+            <a:srgbClr val="FBF7F2"/>
+          </a:solidFill>
+          <a:ln w="12700">
+            <a:solidFill>
+              <a:srgbClr val="FBF7F2">
+                <a:alpha val="0"/>
+              </a:srgbClr>
+            </a:solidFill>
+            <a:prstDash val="solid"/>
+          </a:ln>
+        </p:spPr>
+      </p:sp>
+      <p:sp>
+        <p:nvSpPr>
+          <p:cNvPr id="10" name="Shape 8"/>
+          <p:cNvSpPr/>
+          <p:nvPr/>
+        </p:nvSpPr>
+        <p:spPr>
+          <a:xfrm>
+            <a:off x="8655389" y="2967382"/>
+            <a:ext cx="299557" cy="41938"/>
+          </a:xfrm>
+          <a:prstGeom prst="rect">
+            <a:avLst/>
+          </a:prstGeom>
+          <a:solidFill>
+            <a:srgbClr val="FBF7F2"/>
+          </a:solidFill>
+          <a:ln w="12700">
+            <a:solidFill>
+              <a:srgbClr val="FBF7F2">
+                <a:alpha val="0"/>
+              </a:srgbClr>
+            </a:solidFill>
+            <a:prstDash val="solid"/>
+          </a:ln>
+        </p:spPr>
+      </p:sp>
+      <p:sp>
+        <p:nvSpPr>
+          <p:cNvPr id="11" name="Shape 9"/>
+          <p:cNvSpPr/>
+          <p:nvPr/>
+        </p:nvSpPr>
+        <p:spPr>
+          <a:xfrm>
+            <a:off x="822960" y="1572768"/>
+            <a:ext cx="6629400" cy="3310128"/>
+          </a:xfrm>
+          <a:prstGeom prst="roundRect">
+            <a:avLst>
+              <a:gd name="adj" fmla="val 1657"/>
+            </a:avLst>
+          </a:prstGeom>
+          <a:solidFill>
+            <a:srgbClr val="FBF7F2"/>
+          </a:solidFill>
+          <a:ln w="12700">
+            <a:solidFill>
+              <a:srgbClr val="E3CDBA">
+                <a:alpha val="90000"/>
+              </a:srgbClr>
+            </a:solidFill>
+            <a:prstDash val="solid"/>
+          </a:ln>
+        </p:spPr>
+      </p:sp>
+      <p:sp>
+        <p:nvSpPr>
+          <p:cNvPr id="12" name="Text 10"/>
           <p:cNvSpPr txBox="1"/>
           <p:nvPr/>
         </p:nvSpPr>
@@ -3717,14 +4292,14 @@
       </p:sp>
       <p:sp>
         <p:nvSpPr>
-          <p:cNvPr id="7" name="Text 5"/>
+          <p:cNvPr id="13" name="Text 11"/>
           <p:cNvSpPr txBox="1"/>
           <p:nvPr/>
         </p:nvSpPr>
         <p:spPr>
           <a:xfrm>
-            <a:off x="987552" y="1572768"/>
-            <a:ext cx="10094976" cy="4261104"/>
+            <a:off x="1115568" y="1773936"/>
+            <a:ext cx="6044184" cy="2907792"/>
           </a:xfrm>
           <a:prstGeom prst="rect">
             <a:avLst/>
@@ -3733,7 +4308,7 @@
           <a:ln/>
         </p:spPr>
         <p:txBody>
-          <a:bodyPr wrap="square" lIns="0" tIns="25400" rIns="25400" bIns="0" rtlCol="0" anchor="t">
+          <a:bodyPr wrap="square" lIns="0" tIns="25400" rIns="25400" bIns="0" rtlCol="0" anchor="ctr">
             <a:normAutofit/>
           </a:bodyPr>
           <a:lstStyle/>
@@ -3985,8 +4560,8 @@
         </p:nvSpPr>
         <p:spPr>
           <a:xfrm>
-            <a:off x="804672" y="2939796"/>
-            <a:ext cx="310896" cy="310896"/>
+            <a:off x="804672" y="2907975"/>
+            <a:ext cx="374538" cy="374538"/>
           </a:xfrm>
           <a:prstGeom prst="ellipse">
             <a:avLst/>
@@ -4012,8 +4587,8 @@
         </p:nvSpPr>
         <p:spPr>
           <a:xfrm>
-            <a:off x="804672" y="2939796"/>
-            <a:ext cx="310896" cy="310896"/>
+            <a:off x="804672" y="2907975"/>
+            <a:ext cx="374538" cy="374538"/>
           </a:xfrm>
           <a:prstGeom prst="rect">
             <a:avLst/>
@@ -4032,7 +4607,7 @@
               <a:buNone/>
             </a:pPr>
             <a:r>
-              <a:rPr lang="en-US" sz="1100" b="1" dirty="0">
+              <a:rPr lang="en-US" sz="1500" b="1" dirty="0">
                 <a:solidFill>
                   <a:srgbClr val="F7F3EF"/>
                 </a:solidFill>
@@ -4042,7 +4617,7 @@
               </a:rPr>
               <a:t>1</a:t>
             </a:r>
-            <a:endParaRPr lang="en-US" sz="1100" dirty="0"/>
+            <a:endParaRPr lang="en-US" sz="1500" dirty="0"/>
           </a:p>
         </p:txBody>
       </p:sp>
@@ -4054,8 +4629,8 @@
         </p:nvSpPr>
         <p:spPr>
           <a:xfrm>
-            <a:off x="1261872" y="2638044"/>
-            <a:ext cx="2648712" cy="914400"/>
+            <a:off x="1325514" y="2638044"/>
+            <a:ext cx="2585070" cy="914400"/>
           </a:xfrm>
           <a:prstGeom prst="rect">
             <a:avLst/>
@@ -4076,7 +4651,7 @@
               <a:buNone/>
             </a:pPr>
             <a:r>
-              <a:rPr lang="en-US" sz="1500" dirty="0">
+              <a:rPr lang="en-US" sz="1600" dirty="0">
                 <a:solidFill>
                   <a:srgbClr val="1F2937"/>
                 </a:solidFill>
@@ -4086,7 +4661,7 @@
               </a:rPr>
               <a:t>Markdown</a:t>
             </a:r>
-            <a:endParaRPr lang="en-US" sz="1500" dirty="0"/>
+            <a:endParaRPr lang="en-US" sz="1600" dirty="0"/>
           </a:p>
         </p:txBody>
       </p:sp>
@@ -4159,8 +4734,8 @@
         </p:nvSpPr>
         <p:spPr>
           <a:xfrm>
-            <a:off x="4550664" y="2939796"/>
-            <a:ext cx="310896" cy="310896"/>
+            <a:off x="4550664" y="2907975"/>
+            <a:ext cx="374538" cy="374538"/>
           </a:xfrm>
           <a:prstGeom prst="ellipse">
             <a:avLst/>
@@ -4186,8 +4761,8 @@
         </p:nvSpPr>
         <p:spPr>
           <a:xfrm>
-            <a:off x="4550664" y="2939796"/>
-            <a:ext cx="310896" cy="310896"/>
+            <a:off x="4550664" y="2907975"/>
+            <a:ext cx="374538" cy="374538"/>
           </a:xfrm>
           <a:prstGeom prst="rect">
             <a:avLst/>
@@ -4206,7 +4781,7 @@
               <a:buNone/>
             </a:pPr>
             <a:r>
-              <a:rPr lang="en-US" sz="1100" b="1" dirty="0">
+              <a:rPr lang="en-US" sz="1500" b="1" dirty="0">
                 <a:solidFill>
                   <a:srgbClr val="F7F3EF"/>
                 </a:solidFill>
@@ -4216,7 +4791,7 @@
               </a:rPr>
               <a:t>2</a:t>
             </a:r>
-            <a:endParaRPr lang="en-US" sz="1100" dirty="0"/>
+            <a:endParaRPr lang="en-US" sz="1500" dirty="0"/>
           </a:p>
         </p:txBody>
       </p:sp>
@@ -4228,8 +4803,8 @@
         </p:nvSpPr>
         <p:spPr>
           <a:xfrm>
-            <a:off x="5007864" y="2638044"/>
-            <a:ext cx="2648712" cy="914400"/>
+            <a:off x="5071506" y="2638044"/>
+            <a:ext cx="2585070" cy="914400"/>
           </a:xfrm>
           <a:prstGeom prst="rect">
             <a:avLst/>
@@ -4250,7 +4825,7 @@
               <a:buNone/>
             </a:pPr>
             <a:r>
-              <a:rPr lang="en-US" sz="1500" dirty="0">
+              <a:rPr lang="en-US" sz="1600" dirty="0">
                 <a:solidFill>
                   <a:srgbClr val="1F2937"/>
                 </a:solidFill>
@@ -4260,7 +4835,7 @@
               </a:rPr>
               <a:t>Presentation IR</a:t>
             </a:r>
-            <a:endParaRPr lang="en-US" sz="1500" dirty="0"/>
+            <a:endParaRPr lang="en-US" sz="1600" dirty="0"/>
           </a:p>
         </p:txBody>
       </p:sp>
@@ -4333,8 +4908,8 @@
         </p:nvSpPr>
         <p:spPr>
           <a:xfrm>
-            <a:off x="8296656" y="2939796"/>
-            <a:ext cx="310896" cy="310896"/>
+            <a:off x="8296656" y="2907975"/>
+            <a:ext cx="374538" cy="374538"/>
           </a:xfrm>
           <a:prstGeom prst="ellipse">
             <a:avLst/>
@@ -4360,8 +4935,8 @@
         </p:nvSpPr>
         <p:spPr>
           <a:xfrm>
-            <a:off x="8296656" y="2939796"/>
-            <a:ext cx="310896" cy="310896"/>
+            <a:off x="8296656" y="2907975"/>
+            <a:ext cx="374538" cy="374538"/>
           </a:xfrm>
           <a:prstGeom prst="rect">
             <a:avLst/>
@@ -4380,7 +4955,7 @@
               <a:buNone/>
             </a:pPr>
             <a:r>
-              <a:rPr lang="en-US" sz="1100" b="1" dirty="0">
+              <a:rPr lang="en-US" sz="1500" b="1" dirty="0">
                 <a:solidFill>
                   <a:srgbClr val="F7F3EF"/>
                 </a:solidFill>
@@ -4390,7 +4965,7 @@
               </a:rPr>
               <a:t>3</a:t>
             </a:r>
-            <a:endParaRPr lang="en-US" sz="1100" dirty="0"/>
+            <a:endParaRPr lang="en-US" sz="1500" dirty="0"/>
           </a:p>
         </p:txBody>
       </p:sp>
@@ -4402,8 +4977,8 @@
         </p:nvSpPr>
         <p:spPr>
           <a:xfrm>
-            <a:off x="8753856" y="2638044"/>
-            <a:ext cx="2648712" cy="914400"/>
+            <a:off x="8817498" y="2638044"/>
+            <a:ext cx="2585070" cy="914400"/>
           </a:xfrm>
           <a:prstGeom prst="rect">
             <a:avLst/>
@@ -4424,7 +4999,7 @@
               <a:buNone/>
             </a:pPr>
             <a:r>
-              <a:rPr lang="en-US" sz="1500" dirty="0">
+              <a:rPr lang="en-US" sz="1600" dirty="0">
                 <a:solidFill>
                   <a:srgbClr val="1F2937"/>
                 </a:solidFill>
@@ -4434,7 +5009,7 @@
               </a:rPr>
               <a:t>optional semantic hints</a:t>
             </a:r>
-            <a:endParaRPr lang="en-US" sz="1500" dirty="0"/>
+            <a:endParaRPr lang="en-US" sz="1600" dirty="0"/>
           </a:p>
         </p:txBody>
       </p:sp>
@@ -4507,8 +5082,8 @@
         </p:nvSpPr>
         <p:spPr>
           <a:xfrm>
-            <a:off x="8296656" y="4421124"/>
-            <a:ext cx="310896" cy="310896"/>
+            <a:off x="8296656" y="4389303"/>
+            <a:ext cx="374538" cy="374538"/>
           </a:xfrm>
           <a:prstGeom prst="ellipse">
             <a:avLst/>
@@ -4534,8 +5109,8 @@
         </p:nvSpPr>
         <p:spPr>
           <a:xfrm>
-            <a:off x="8296656" y="4421124"/>
-            <a:ext cx="310896" cy="310896"/>
+            <a:off x="8296656" y="4389303"/>
+            <a:ext cx="374538" cy="374538"/>
           </a:xfrm>
           <a:prstGeom prst="rect">
             <a:avLst/>
@@ -4554,7 +5129,7 @@
               <a:buNone/>
             </a:pPr>
             <a:r>
-              <a:rPr lang="en-US" sz="1100" b="1" dirty="0">
+              <a:rPr lang="en-US" sz="1500" b="1" dirty="0">
                 <a:solidFill>
                   <a:srgbClr val="F7F3EF"/>
                 </a:solidFill>
@@ -4564,7 +5139,7 @@
               </a:rPr>
               <a:t>4</a:t>
             </a:r>
-            <a:endParaRPr lang="en-US" sz="1100" dirty="0"/>
+            <a:endParaRPr lang="en-US" sz="1500" dirty="0"/>
           </a:p>
         </p:txBody>
       </p:sp>
@@ -4576,8 +5151,8 @@
         </p:nvSpPr>
         <p:spPr>
           <a:xfrm>
-            <a:off x="8753856" y="4119372"/>
-            <a:ext cx="2648712" cy="914400"/>
+            <a:off x="8817498" y="4119372"/>
+            <a:ext cx="2585070" cy="914400"/>
           </a:xfrm>
           <a:prstGeom prst="rect">
             <a:avLst/>
@@ -4598,7 +5173,7 @@
               <a:buNone/>
             </a:pPr>
             <a:r>
-              <a:rPr lang="en-US" sz="1500" dirty="0">
+              <a:rPr lang="en-US" sz="1600" dirty="0">
                 <a:solidFill>
                   <a:srgbClr val="1F2937"/>
                 </a:solidFill>
@@ -4608,7 +5183,7 @@
               </a:rPr>
               <a:t>Layout IR</a:t>
             </a:r>
-            <a:endParaRPr lang="en-US" sz="1500" dirty="0"/>
+            <a:endParaRPr lang="en-US" sz="1600" dirty="0"/>
           </a:p>
         </p:txBody>
       </p:sp>
@@ -4681,8 +5256,8 @@
         </p:nvSpPr>
         <p:spPr>
           <a:xfrm>
-            <a:off x="4550664" y="4421124"/>
-            <a:ext cx="310896" cy="310896"/>
+            <a:off x="4550664" y="4389303"/>
+            <a:ext cx="374538" cy="374538"/>
           </a:xfrm>
           <a:prstGeom prst="ellipse">
             <a:avLst/>
@@ -4708,8 +5283,8 @@
         </p:nvSpPr>
         <p:spPr>
           <a:xfrm>
-            <a:off x="4550664" y="4421124"/>
-            <a:ext cx="310896" cy="310896"/>
+            <a:off x="4550664" y="4389303"/>
+            <a:ext cx="374538" cy="374538"/>
           </a:xfrm>
           <a:prstGeom prst="rect">
             <a:avLst/>
@@ -4728,7 +5303,7 @@
               <a:buNone/>
             </a:pPr>
             <a:r>
-              <a:rPr lang="en-US" sz="1100" b="1" dirty="0">
+              <a:rPr lang="en-US" sz="1500" b="1" dirty="0">
                 <a:solidFill>
                   <a:srgbClr val="F7F3EF"/>
                 </a:solidFill>
@@ -4738,7 +5313,7 @@
               </a:rPr>
               <a:t>5</a:t>
             </a:r>
-            <a:endParaRPr lang="en-US" sz="1100" dirty="0"/>
+            <a:endParaRPr lang="en-US" sz="1500" dirty="0"/>
           </a:p>
         </p:txBody>
       </p:sp>
@@ -4750,8 +5325,8 @@
         </p:nvSpPr>
         <p:spPr>
           <a:xfrm>
-            <a:off x="5007864" y="4119372"/>
-            <a:ext cx="2648712" cy="914400"/>
+            <a:off x="5071506" y="4119372"/>
+            <a:ext cx="2585070" cy="914400"/>
           </a:xfrm>
           <a:prstGeom prst="rect">
             <a:avLst/>
@@ -4772,7 +5347,7 @@
               <a:buNone/>
             </a:pPr>
             <a:r>
-              <a:rPr lang="en-US" sz="1500" dirty="0">
+              <a:rPr lang="en-US" sz="1600" dirty="0">
                 <a:solidFill>
                   <a:srgbClr val="1F2937"/>
                 </a:solidFill>
@@ -4782,7 +5357,7 @@
               </a:rPr>
               <a:t>PPTX theme colors</a:t>
             </a:r>
-            <a:endParaRPr lang="en-US" sz="1500" dirty="0"/>
+            <a:endParaRPr lang="en-US" sz="1600" dirty="0"/>
           </a:p>
         </p:txBody>
       </p:sp>
@@ -4855,8 +5430,8 @@
         </p:nvSpPr>
         <p:spPr>
           <a:xfrm>
-            <a:off x="804672" y="4421124"/>
-            <a:ext cx="310896" cy="310896"/>
+            <a:off x="804672" y="4389303"/>
+            <a:ext cx="374538" cy="374538"/>
           </a:xfrm>
           <a:prstGeom prst="ellipse">
             <a:avLst/>
@@ -4882,8 +5457,8 @@
         </p:nvSpPr>
         <p:spPr>
           <a:xfrm>
-            <a:off x="804672" y="4421124"/>
-            <a:ext cx="310896" cy="310896"/>
+            <a:off x="804672" y="4389303"/>
+            <a:ext cx="374538" cy="374538"/>
           </a:xfrm>
           <a:prstGeom prst="rect">
             <a:avLst/>
@@ -4902,7 +5477,7 @@
               <a:buNone/>
             </a:pPr>
             <a:r>
-              <a:rPr lang="en-US" sz="1100" b="1" dirty="0">
+              <a:rPr lang="en-US" sz="1500" b="1" dirty="0">
                 <a:solidFill>
                   <a:srgbClr val="F7F3EF"/>
                 </a:solidFill>
@@ -4912,7 +5487,7 @@
               </a:rPr>
               <a:t>6</a:t>
             </a:r>
-            <a:endParaRPr lang="en-US" sz="1100" dirty="0"/>
+            <a:endParaRPr lang="en-US" sz="1500" dirty="0"/>
           </a:p>
         </p:txBody>
       </p:sp>
@@ -4924,8 +5499,8 @@
         </p:nvSpPr>
         <p:spPr>
           <a:xfrm>
-            <a:off x="1261872" y="4119372"/>
-            <a:ext cx="2648712" cy="914400"/>
+            <a:off x="1325514" y="4119372"/>
+            <a:ext cx="2585070" cy="914400"/>
           </a:xfrm>
           <a:prstGeom prst="rect">
             <a:avLst/>
@@ -4946,7 +5521,7 @@
               <a:buNone/>
             </a:pPr>
             <a:r>
-              <a:rPr lang="en-US" sz="1500" dirty="0">
+              <a:rPr lang="en-US" sz="1600" dirty="0">
                 <a:solidFill>
                   <a:srgbClr val="1F2937"/>
                 </a:solidFill>
@@ -4956,7 +5531,7 @@
               </a:rPr>
               <a:t>visual QA</a:t>
             </a:r>
-            <a:endParaRPr lang="en-US" sz="1500" dirty="0"/>
+            <a:endParaRPr lang="en-US" sz="1600" dirty="0"/>
           </a:p>
         </p:txBody>
       </p:sp>
@@ -5201,8 +5776,8 @@
         </p:nvSpPr>
         <p:spPr>
           <a:xfrm>
-            <a:off x="914400" y="1463040"/>
-            <a:ext cx="10241280" cy="73152"/>
+            <a:off x="822960" y="1572768"/>
+            <a:ext cx="6629400" cy="73152"/>
           </a:xfrm>
           <a:prstGeom prst="rect">
             <a:avLst/>
@@ -5222,7 +5797,180 @@
       </p:sp>
       <p:sp>
         <p:nvSpPr>
-          <p:cNvPr id="6" name="Text 4"/>
+          <p:cNvPr id="6" name="Shape 4"/>
+          <p:cNvSpPr/>
+          <p:nvPr/>
+        </p:nvSpPr>
+        <p:spPr>
+          <a:xfrm>
+            <a:off x="7955280" y="1993392"/>
+            <a:ext cx="2139696" cy="2139696"/>
+          </a:xfrm>
+          <a:prstGeom prst="roundRect">
+            <a:avLst>
+              <a:gd name="adj" fmla="val 3419"/>
+            </a:avLst>
+          </a:prstGeom>
+          <a:solidFill>
+            <a:srgbClr val="FBF7F2"/>
+          </a:solidFill>
+          <a:ln w="12700">
+            <a:solidFill>
+              <a:srgbClr val="E3CDBA"/>
+            </a:solidFill>
+            <a:prstDash val="solid"/>
+          </a:ln>
+          <a:effectLst>
+            <a:outerShdw sx="100000" sy="100000" kx="0" ky="0" algn="bl" rotWithShape="0" blurRad="12700" dist="50800" dir="2700000">
+              <a:srgbClr val="000000">
+                <a:alpha val="8000"/>
+              </a:srgbClr>
+            </a:outerShdw>
+          </a:effectLst>
+        </p:spPr>
+      </p:sp>
+      <p:sp>
+        <p:nvSpPr>
+          <p:cNvPr id="7" name="Shape 5"/>
+          <p:cNvSpPr/>
+          <p:nvPr/>
+        </p:nvSpPr>
+        <p:spPr>
+          <a:xfrm>
+            <a:off x="8511601" y="2464125"/>
+            <a:ext cx="575150" cy="742902"/>
+          </a:xfrm>
+          <a:prstGeom prst="roundRect">
+            <a:avLst>
+              <a:gd name="adj" fmla="val 6359"/>
+            </a:avLst>
+          </a:prstGeom>
+          <a:solidFill>
+            <a:srgbClr val="1F2937"/>
+          </a:solidFill>
+          <a:ln w="12700">
+            <a:solidFill>
+              <a:srgbClr val="1F2937">
+                <a:alpha val="0"/>
+              </a:srgbClr>
+            </a:solidFill>
+            <a:prstDash val="solid"/>
+          </a:ln>
+        </p:spPr>
+      </p:sp>
+      <p:sp>
+        <p:nvSpPr>
+          <p:cNvPr id="8" name="Shape 6"/>
+          <p:cNvSpPr/>
+          <p:nvPr/>
+        </p:nvSpPr>
+        <p:spPr>
+          <a:xfrm>
+            <a:off x="8655389" y="2655842"/>
+            <a:ext cx="299557" cy="41938"/>
+          </a:xfrm>
+          <a:prstGeom prst="rect">
+            <a:avLst/>
+          </a:prstGeom>
+          <a:solidFill>
+            <a:srgbClr val="FBF7F2"/>
+          </a:solidFill>
+          <a:ln w="12700">
+            <a:solidFill>
+              <a:srgbClr val="FBF7F2">
+                <a:alpha val="0"/>
+              </a:srgbClr>
+            </a:solidFill>
+            <a:prstDash val="solid"/>
+          </a:ln>
+        </p:spPr>
+      </p:sp>
+      <p:sp>
+        <p:nvSpPr>
+          <p:cNvPr id="9" name="Shape 7"/>
+          <p:cNvSpPr/>
+          <p:nvPr/>
+        </p:nvSpPr>
+        <p:spPr>
+          <a:xfrm>
+            <a:off x="8655389" y="2811612"/>
+            <a:ext cx="299557" cy="41938"/>
+          </a:xfrm>
+          <a:prstGeom prst="rect">
+            <a:avLst/>
+          </a:prstGeom>
+          <a:solidFill>
+            <a:srgbClr val="FBF7F2"/>
+          </a:solidFill>
+          <a:ln w="12700">
+            <a:solidFill>
+              <a:srgbClr val="FBF7F2">
+                <a:alpha val="0"/>
+              </a:srgbClr>
+            </a:solidFill>
+            <a:prstDash val="solid"/>
+          </a:ln>
+        </p:spPr>
+      </p:sp>
+      <p:sp>
+        <p:nvSpPr>
+          <p:cNvPr id="10" name="Shape 8"/>
+          <p:cNvSpPr/>
+          <p:nvPr/>
+        </p:nvSpPr>
+        <p:spPr>
+          <a:xfrm>
+            <a:off x="8655389" y="2967382"/>
+            <a:ext cx="299557" cy="41938"/>
+          </a:xfrm>
+          <a:prstGeom prst="rect">
+            <a:avLst/>
+          </a:prstGeom>
+          <a:solidFill>
+            <a:srgbClr val="FBF7F2"/>
+          </a:solidFill>
+          <a:ln w="12700">
+            <a:solidFill>
+              <a:srgbClr val="FBF7F2">
+                <a:alpha val="0"/>
+              </a:srgbClr>
+            </a:solidFill>
+            <a:prstDash val="solid"/>
+          </a:ln>
+        </p:spPr>
+      </p:sp>
+      <p:sp>
+        <p:nvSpPr>
+          <p:cNvPr id="11" name="Shape 9"/>
+          <p:cNvSpPr/>
+          <p:nvPr/>
+        </p:nvSpPr>
+        <p:spPr>
+          <a:xfrm>
+            <a:off x="822960" y="1572768"/>
+            <a:ext cx="6629400" cy="3310128"/>
+          </a:xfrm>
+          <a:prstGeom prst="roundRect">
+            <a:avLst>
+              <a:gd name="adj" fmla="val 1657"/>
+            </a:avLst>
+          </a:prstGeom>
+          <a:solidFill>
+            <a:srgbClr val="FBF7F2"/>
+          </a:solidFill>
+          <a:ln w="12700">
+            <a:solidFill>
+              <a:srgbClr val="E3CDBA">
+                <a:alpha val="90000"/>
+              </a:srgbClr>
+            </a:solidFill>
+            <a:prstDash val="solid"/>
+          </a:ln>
+        </p:spPr>
+      </p:sp>
+      <p:sp>
+        <p:nvSpPr>
+          <p:cNvPr id="12" name="Text 10"/>
           <p:cNvSpPr txBox="1"/>
           <p:nvPr/>
         </p:nvSpPr>
@@ -5266,14 +6014,14 @@
       </p:sp>
       <p:sp>
         <p:nvSpPr>
-          <p:cNvPr id="7" name="Text 5"/>
+          <p:cNvPr id="13" name="Text 11"/>
           <p:cNvSpPr txBox="1"/>
           <p:nvPr/>
         </p:nvSpPr>
         <p:spPr>
           <a:xfrm>
-            <a:off x="987552" y="1572768"/>
-            <a:ext cx="10094976" cy="4261104"/>
+            <a:off x="1115568" y="1773936"/>
+            <a:ext cx="6044184" cy="2907792"/>
           </a:xfrm>
           <a:prstGeom prst="rect">
             <a:avLst/>
@@ -5282,7 +6030,7 @@
           <a:ln/>
         </p:spPr>
         <p:txBody>
-          <a:bodyPr wrap="square" lIns="0" tIns="25400" rIns="25400" bIns="0" rtlCol="0" anchor="t">
+          <a:bodyPr wrap="square" lIns="0" tIns="25400" rIns="25400" bIns="0" rtlCol="0" anchor="ctr">
             <a:normAutofit/>
           </a:bodyPr>
           <a:lstStyle/>

</xml_diff>